<commit_message>
Update after first round presentation
</commit_message>
<xml_diff>
--- a/screen-with-gpt-models.pptx
+++ b/screen-with-gpt-models.pptx
@@ -245,7 +245,7 @@
           <a:p>
             <a:fld id="{7BEB8190-3B91-4E7B-8634-E458355F2E20}" type="datetimeFigureOut">
               <a:rPr lang="en-GB" smtClean="0"/>
-              <a:t>21/04/2026</a:t>
+              <a:t>22/04/2026</a:t>
             </a:fld>
             <a:endParaRPr lang="en-GB"/>
           </a:p>
@@ -45192,360 +45192,6 @@
           <a:chExt cx="0" cy="0"/>
         </a:xfrm>
       </p:grpSpPr>
-      <p:sp>
-        <p:nvSpPr>
-          <p:cNvPr id="4" name="Text Placeholder 2">
-            <a:extLst>
-              <a:ext uri="{FF2B5EF4-FFF2-40B4-BE49-F238E27FC236}">
-                <a16:creationId xmlns:a16="http://schemas.microsoft.com/office/drawing/2014/main" id="{53354405-76D0-4268-8EE0-44258B5D5318}"/>
-              </a:ext>
-            </a:extLst>
-          </p:cNvPr>
-          <p:cNvSpPr txBox="1">
-            <a:spLocks/>
-          </p:cNvSpPr>
-          <p:nvPr/>
-        </p:nvSpPr>
-        <p:spPr>
-          <a:xfrm>
-            <a:off x="1013520" y="1119244"/>
-            <a:ext cx="4791378" cy="4911441"/>
-          </a:xfrm>
-          <a:prstGeom prst="rect">
-            <a:avLst/>
-          </a:prstGeom>
-        </p:spPr>
-        <p:txBody>
-          <a:bodyPr vert="horz" lIns="0" tIns="0" rIns="0" bIns="0" rtlCol="0" anchor="t">
-            <a:noAutofit/>
-          </a:bodyPr>
-          <a:lstStyle>
-            <a:lvl1pPr marL="285750" indent="-285750" algn="l" defTabSz="914400" rtl="0" eaLnBrk="1" latinLnBrk="0" hangingPunct="1">
-              <a:lnSpc>
-                <a:spcPct val="100000"/>
-              </a:lnSpc>
-              <a:spcBef>
-                <a:spcPts val="1000"/>
-              </a:spcBef>
-              <a:buClr>
-                <a:schemeClr val="bg1"/>
-              </a:buClr>
-              <a:buSzPct val="110000"/>
-              <a:buFontTx/>
-              <a:buBlip>
-                <a:blip r:embed="rId2">
-                  <a:extLst>
-                    <a:ext uri="{96DAC541-7B7A-43D3-8B79-37D633B846F1}">
-                      <asvg:svgBlip xmlns:asvg="http://schemas.microsoft.com/office/drawing/2016/SVG/main" r:embed="rId3"/>
-                    </a:ext>
-                  </a:extLst>
-                </a:blip>
-              </a:buBlip>
-              <a:defRPr sz="1800" kern="1200">
-                <a:solidFill>
-                  <a:schemeClr val="tx1"/>
-                </a:solidFill>
-                <a:latin typeface="+mn-lt"/>
-                <a:ea typeface="+mn-ea"/>
-                <a:cs typeface="+mn-cs"/>
-              </a:defRPr>
-            </a:lvl1pPr>
-            <a:lvl2pPr marL="603250" indent="-285750" algn="l" defTabSz="914400" rtl="0" eaLnBrk="1" latinLnBrk="0" hangingPunct="1">
-              <a:lnSpc>
-                <a:spcPct val="100000"/>
-              </a:lnSpc>
-              <a:spcBef>
-                <a:spcPts val="1000"/>
-              </a:spcBef>
-              <a:buClr>
-                <a:schemeClr val="bg1"/>
-              </a:buClr>
-              <a:buSzPct val="110000"/>
-              <a:buFontTx/>
-              <a:buBlip>
-                <a:blip r:embed="rId2">
-                  <a:extLst>
-                    <a:ext uri="{96DAC541-7B7A-43D3-8B79-37D633B846F1}">
-                      <asvg:svgBlip xmlns:asvg="http://schemas.microsoft.com/office/drawing/2016/SVG/main" r:embed="rId3"/>
-                    </a:ext>
-                  </a:extLst>
-                </a:blip>
-              </a:buBlip>
-              <a:defRPr sz="1600" kern="1200">
-                <a:solidFill>
-                  <a:schemeClr val="tx1"/>
-                </a:solidFill>
-                <a:latin typeface="+mn-lt"/>
-                <a:ea typeface="+mn-ea"/>
-                <a:cs typeface="+mn-cs"/>
-              </a:defRPr>
-            </a:lvl2pPr>
-            <a:lvl3pPr marL="920750" indent="-285750" algn="l" defTabSz="914400" rtl="0" eaLnBrk="1" latinLnBrk="0" hangingPunct="1">
-              <a:lnSpc>
-                <a:spcPct val="100000"/>
-              </a:lnSpc>
-              <a:spcBef>
-                <a:spcPts val="1000"/>
-              </a:spcBef>
-              <a:buClr>
-                <a:schemeClr val="bg1"/>
-              </a:buClr>
-              <a:buSzPct val="110000"/>
-              <a:buFontTx/>
-              <a:buBlip>
-                <a:blip r:embed="rId2">
-                  <a:extLst>
-                    <a:ext uri="{96DAC541-7B7A-43D3-8B79-37D633B846F1}">
-                      <asvg:svgBlip xmlns:asvg="http://schemas.microsoft.com/office/drawing/2016/SVG/main" r:embed="rId3"/>
-                    </a:ext>
-                  </a:extLst>
-                </a:blip>
-              </a:buBlip>
-              <a:defRPr sz="1400" kern="1200">
-                <a:solidFill>
-                  <a:schemeClr val="tx1"/>
-                </a:solidFill>
-                <a:latin typeface="+mn-lt"/>
-                <a:ea typeface="+mn-ea"/>
-                <a:cs typeface="+mn-cs"/>
-              </a:defRPr>
-            </a:lvl3pPr>
-            <a:lvl4pPr marL="1238250" indent="-285750" algn="l" defTabSz="914400" rtl="0" eaLnBrk="1" latinLnBrk="0" hangingPunct="1">
-              <a:lnSpc>
-                <a:spcPct val="100000"/>
-              </a:lnSpc>
-              <a:spcBef>
-                <a:spcPts val="1000"/>
-              </a:spcBef>
-              <a:buClr>
-                <a:schemeClr val="bg1"/>
-              </a:buClr>
-              <a:buSzPct val="110000"/>
-              <a:buFontTx/>
-              <a:buBlip>
-                <a:blip r:embed="rId2">
-                  <a:extLst>
-                    <a:ext uri="{96DAC541-7B7A-43D3-8B79-37D633B846F1}">
-                      <asvg:svgBlip xmlns:asvg="http://schemas.microsoft.com/office/drawing/2016/SVG/main" r:embed="rId3"/>
-                    </a:ext>
-                  </a:extLst>
-                </a:blip>
-              </a:buBlip>
-              <a:defRPr sz="1200" kern="1200">
-                <a:solidFill>
-                  <a:schemeClr val="tx1"/>
-                </a:solidFill>
-                <a:latin typeface="+mn-lt"/>
-                <a:ea typeface="+mn-ea"/>
-                <a:cs typeface="+mn-cs"/>
-              </a:defRPr>
-            </a:lvl4pPr>
-            <a:lvl5pPr marL="1555750" indent="-285750" algn="l" defTabSz="914400" rtl="0" eaLnBrk="1" latinLnBrk="0" hangingPunct="1">
-              <a:lnSpc>
-                <a:spcPct val="100000"/>
-              </a:lnSpc>
-              <a:spcBef>
-                <a:spcPts val="1000"/>
-              </a:spcBef>
-              <a:buClr>
-                <a:schemeClr val="bg1"/>
-              </a:buClr>
-              <a:buSzPct val="110000"/>
-              <a:buFontTx/>
-              <a:buBlip>
-                <a:blip r:embed="rId2">
-                  <a:extLst>
-                    <a:ext uri="{96DAC541-7B7A-43D3-8B79-37D633B846F1}">
-                      <asvg:svgBlip xmlns:asvg="http://schemas.microsoft.com/office/drawing/2016/SVG/main" r:embed="rId3"/>
-                    </a:ext>
-                  </a:extLst>
-                </a:blip>
-              </a:buBlip>
-              <a:defRPr sz="1000" kern="1200">
-                <a:solidFill>
-                  <a:schemeClr val="tx1"/>
-                </a:solidFill>
-                <a:latin typeface="+mn-lt"/>
-                <a:ea typeface="+mn-ea"/>
-                <a:cs typeface="+mn-cs"/>
-              </a:defRPr>
-            </a:lvl5pPr>
-            <a:lvl6pPr marL="2514600" indent="-228600" algn="l" defTabSz="914400" rtl="0" eaLnBrk="1" latinLnBrk="0" hangingPunct="1">
-              <a:lnSpc>
-                <a:spcPct val="90000"/>
-              </a:lnSpc>
-              <a:spcBef>
-                <a:spcPts val="500"/>
-              </a:spcBef>
-              <a:buFont typeface="Arial" panose="020B0604020202020204" pitchFamily="34" charset="0"/>
-              <a:buChar char="•"/>
-              <a:defRPr sz="1800" kern="1200">
-                <a:solidFill>
-                  <a:schemeClr val="tx1"/>
-                </a:solidFill>
-                <a:latin typeface="+mn-lt"/>
-                <a:ea typeface="+mn-ea"/>
-                <a:cs typeface="+mn-cs"/>
-              </a:defRPr>
-            </a:lvl6pPr>
-            <a:lvl7pPr marL="2971800" indent="-228600" algn="l" defTabSz="914400" rtl="0" eaLnBrk="1" latinLnBrk="0" hangingPunct="1">
-              <a:lnSpc>
-                <a:spcPct val="90000"/>
-              </a:lnSpc>
-              <a:spcBef>
-                <a:spcPts val="500"/>
-              </a:spcBef>
-              <a:buFont typeface="Arial" panose="020B0604020202020204" pitchFamily="34" charset="0"/>
-              <a:buChar char="•"/>
-              <a:defRPr sz="1800" kern="1200">
-                <a:solidFill>
-                  <a:schemeClr val="tx1"/>
-                </a:solidFill>
-                <a:latin typeface="+mn-lt"/>
-                <a:ea typeface="+mn-ea"/>
-                <a:cs typeface="+mn-cs"/>
-              </a:defRPr>
-            </a:lvl7pPr>
-            <a:lvl8pPr marL="3429000" indent="-228600" algn="l" defTabSz="914400" rtl="0" eaLnBrk="1" latinLnBrk="0" hangingPunct="1">
-              <a:lnSpc>
-                <a:spcPct val="90000"/>
-              </a:lnSpc>
-              <a:spcBef>
-                <a:spcPts val="500"/>
-              </a:spcBef>
-              <a:buFont typeface="Arial" panose="020B0604020202020204" pitchFamily="34" charset="0"/>
-              <a:buChar char="•"/>
-              <a:defRPr sz="1800" kern="1200">
-                <a:solidFill>
-                  <a:schemeClr val="tx1"/>
-                </a:solidFill>
-                <a:latin typeface="+mn-lt"/>
-                <a:ea typeface="+mn-ea"/>
-                <a:cs typeface="+mn-cs"/>
-              </a:defRPr>
-            </a:lvl8pPr>
-            <a:lvl9pPr marL="3886200" indent="-228600" algn="l" defTabSz="914400" rtl="0" eaLnBrk="1" latinLnBrk="0" hangingPunct="1">
-              <a:lnSpc>
-                <a:spcPct val="90000"/>
-              </a:lnSpc>
-              <a:spcBef>
-                <a:spcPts val="500"/>
-              </a:spcBef>
-              <a:buFont typeface="Arial" panose="020B0604020202020204" pitchFamily="34" charset="0"/>
-              <a:buChar char="•"/>
-              <a:defRPr sz="1800" kern="1200">
-                <a:solidFill>
-                  <a:schemeClr val="tx1"/>
-                </a:solidFill>
-                <a:latin typeface="+mn-lt"/>
-                <a:ea typeface="+mn-ea"/>
-                <a:cs typeface="+mn-cs"/>
-              </a:defRPr>
-            </a:lvl9pPr>
-          </a:lstStyle>
-          <a:p>
-            <a:pPr marL="0" indent="0">
-              <a:buNone/>
-            </a:pPr>
-            <a:r>
-              <a:rPr lang="en-US" sz="2400" b="1" dirty="0"/>
-              <a:t>Advantages</a:t>
-            </a:r>
-          </a:p>
-          <a:p>
-            <a:pPr>
-              <a:spcAft>
-                <a:spcPts val="800"/>
-              </a:spcAft>
-            </a:pPr>
-            <a:r>
-              <a:rPr lang="en-US" dirty="0"/>
-              <a:t>Equal treatment of all titles and abstracts</a:t>
-            </a:r>
-          </a:p>
-          <a:p>
-            <a:pPr>
-              <a:spcAft>
-                <a:spcPts val="800"/>
-              </a:spcAft>
-            </a:pPr>
-            <a:r>
-              <a:rPr lang="en-US" dirty="0"/>
-              <a:t>It is most often accurate</a:t>
-            </a:r>
-          </a:p>
-          <a:p>
-            <a:pPr>
-              <a:spcAft>
-                <a:spcPts val="800"/>
-              </a:spcAft>
-            </a:pPr>
-            <a:r>
-              <a:rPr lang="en-US" dirty="0"/>
-              <a:t>It is fast</a:t>
-            </a:r>
-          </a:p>
-          <a:p>
-            <a:pPr>
-              <a:spcAft>
-                <a:spcPts val="800"/>
-              </a:spcAft>
-            </a:pPr>
-            <a:r>
-              <a:rPr lang="en-US" dirty="0"/>
-              <a:t>It is cheap </a:t>
-            </a:r>
-          </a:p>
-          <a:p>
-            <a:pPr>
-              <a:spcAft>
-                <a:spcPts val="800"/>
-              </a:spcAft>
-            </a:pPr>
-            <a:r>
-              <a:rPr lang="en-US" dirty="0"/>
-              <a:t>Can guard against human drifting. </a:t>
-            </a:r>
-          </a:p>
-          <a:p>
-            <a:pPr>
-              <a:spcAft>
-                <a:spcPts val="800"/>
-              </a:spcAft>
-            </a:pPr>
-            <a:r>
-              <a:rPr lang="en-US" dirty="0"/>
-              <a:t>Extra insurance that you have found all relevant records. It can also be used as a third screener.</a:t>
-            </a:r>
-          </a:p>
-          <a:p>
-            <a:pPr>
-              <a:spcAft>
-                <a:spcPts val="800"/>
-              </a:spcAft>
-            </a:pPr>
-            <a:r>
-              <a:rPr lang="en-US" dirty="0"/>
-              <a:t>Agnostic to data imbalance</a:t>
-            </a:r>
-          </a:p>
-          <a:p>
-            <a:pPr>
-              <a:spcAft>
-                <a:spcPts val="800"/>
-              </a:spcAft>
-            </a:pPr>
-            <a:r>
-              <a:rPr lang="da-DK" dirty="0"/>
-              <a:t>I</a:t>
-            </a:r>
-            <a:r>
-              <a:rPr lang="en-US" dirty="0"/>
-              <a:t>t’s flexible. That is, it can rapidly be fitted to many different situations. </a:t>
-            </a:r>
-          </a:p>
-        </p:txBody>
-      </p:sp>
       <p:cxnSp>
         <p:nvCxnSpPr>
           <p:cNvPr id="8" name="Straight Connector 7">
@@ -45598,7 +45244,7 @@
         </p:nvSpPr>
         <p:spPr>
           <a:xfrm>
-            <a:off x="6460287" y="1119245"/>
+            <a:off x="815487" y="917046"/>
             <a:ext cx="4791378" cy="4586842"/>
           </a:xfrm>
           <a:prstGeom prst="rect">
@@ -45896,6 +45542,371 @@
             <a:r>
               <a:rPr lang="en-US" dirty="0"/>
               <a:t>Hard to keep up with new model developments</a:t>
+            </a:r>
+          </a:p>
+          <a:p>
+            <a:pPr>
+              <a:spcAft>
+                <a:spcPts val="800"/>
+              </a:spcAft>
+            </a:pPr>
+            <a:r>
+              <a:rPr lang="en-US" dirty="0"/>
+              <a:t>Supporting American and Chinese big tech companies. </a:t>
+            </a:r>
+          </a:p>
+        </p:txBody>
+      </p:sp>
+      <p:sp>
+        <p:nvSpPr>
+          <p:cNvPr id="2" name="Text Placeholder 2">
+            <a:extLst>
+              <a:ext uri="{FF2B5EF4-FFF2-40B4-BE49-F238E27FC236}">
+                <a16:creationId xmlns:a16="http://schemas.microsoft.com/office/drawing/2014/main" id="{53354405-76D0-4268-8EE0-44258B5D5318}"/>
+              </a:ext>
+            </a:extLst>
+          </p:cNvPr>
+          <p:cNvSpPr txBox="1">
+            <a:spLocks/>
+          </p:cNvSpPr>
+          <p:nvPr/>
+        </p:nvSpPr>
+        <p:spPr>
+          <a:xfrm>
+            <a:off x="6687120" y="917046"/>
+            <a:ext cx="4791378" cy="5159754"/>
+          </a:xfrm>
+          <a:prstGeom prst="rect">
+            <a:avLst/>
+          </a:prstGeom>
+        </p:spPr>
+        <p:txBody>
+          <a:bodyPr vert="horz" lIns="0" tIns="0" rIns="0" bIns="0" rtlCol="0" anchor="t">
+            <a:noAutofit/>
+          </a:bodyPr>
+          <a:lstStyle>
+            <a:lvl1pPr marL="285750" indent="-285750" algn="l" defTabSz="914400" rtl="0" eaLnBrk="1" latinLnBrk="0" hangingPunct="1">
+              <a:lnSpc>
+                <a:spcPct val="100000"/>
+              </a:lnSpc>
+              <a:spcBef>
+                <a:spcPts val="1000"/>
+              </a:spcBef>
+              <a:buClr>
+                <a:schemeClr val="bg1"/>
+              </a:buClr>
+              <a:buSzPct val="110000"/>
+              <a:buFontTx/>
+              <a:buBlip>
+                <a:blip r:embed="rId2">
+                  <a:extLst>
+                    <a:ext uri="{96DAC541-7B7A-43D3-8B79-37D633B846F1}">
+                      <asvg:svgBlip xmlns:asvg="http://schemas.microsoft.com/office/drawing/2016/SVG/main" r:embed="rId3"/>
+                    </a:ext>
+                  </a:extLst>
+                </a:blip>
+              </a:buBlip>
+              <a:defRPr sz="1800" kern="1200">
+                <a:solidFill>
+                  <a:schemeClr val="tx1"/>
+                </a:solidFill>
+                <a:latin typeface="+mn-lt"/>
+                <a:ea typeface="+mn-ea"/>
+                <a:cs typeface="+mn-cs"/>
+              </a:defRPr>
+            </a:lvl1pPr>
+            <a:lvl2pPr marL="603250" indent="-285750" algn="l" defTabSz="914400" rtl="0" eaLnBrk="1" latinLnBrk="0" hangingPunct="1">
+              <a:lnSpc>
+                <a:spcPct val="100000"/>
+              </a:lnSpc>
+              <a:spcBef>
+                <a:spcPts val="1000"/>
+              </a:spcBef>
+              <a:buClr>
+                <a:schemeClr val="bg1"/>
+              </a:buClr>
+              <a:buSzPct val="110000"/>
+              <a:buFontTx/>
+              <a:buBlip>
+                <a:blip r:embed="rId2">
+                  <a:extLst>
+                    <a:ext uri="{96DAC541-7B7A-43D3-8B79-37D633B846F1}">
+                      <asvg:svgBlip xmlns:asvg="http://schemas.microsoft.com/office/drawing/2016/SVG/main" r:embed="rId3"/>
+                    </a:ext>
+                  </a:extLst>
+                </a:blip>
+              </a:buBlip>
+              <a:defRPr sz="1600" kern="1200">
+                <a:solidFill>
+                  <a:schemeClr val="tx1"/>
+                </a:solidFill>
+                <a:latin typeface="+mn-lt"/>
+                <a:ea typeface="+mn-ea"/>
+                <a:cs typeface="+mn-cs"/>
+              </a:defRPr>
+            </a:lvl2pPr>
+            <a:lvl3pPr marL="920750" indent="-285750" algn="l" defTabSz="914400" rtl="0" eaLnBrk="1" latinLnBrk="0" hangingPunct="1">
+              <a:lnSpc>
+                <a:spcPct val="100000"/>
+              </a:lnSpc>
+              <a:spcBef>
+                <a:spcPts val="1000"/>
+              </a:spcBef>
+              <a:buClr>
+                <a:schemeClr val="bg1"/>
+              </a:buClr>
+              <a:buSzPct val="110000"/>
+              <a:buFontTx/>
+              <a:buBlip>
+                <a:blip r:embed="rId2">
+                  <a:extLst>
+                    <a:ext uri="{96DAC541-7B7A-43D3-8B79-37D633B846F1}">
+                      <asvg:svgBlip xmlns:asvg="http://schemas.microsoft.com/office/drawing/2016/SVG/main" r:embed="rId3"/>
+                    </a:ext>
+                  </a:extLst>
+                </a:blip>
+              </a:buBlip>
+              <a:defRPr sz="1400" kern="1200">
+                <a:solidFill>
+                  <a:schemeClr val="tx1"/>
+                </a:solidFill>
+                <a:latin typeface="+mn-lt"/>
+                <a:ea typeface="+mn-ea"/>
+                <a:cs typeface="+mn-cs"/>
+              </a:defRPr>
+            </a:lvl3pPr>
+            <a:lvl4pPr marL="1238250" indent="-285750" algn="l" defTabSz="914400" rtl="0" eaLnBrk="1" latinLnBrk="0" hangingPunct="1">
+              <a:lnSpc>
+                <a:spcPct val="100000"/>
+              </a:lnSpc>
+              <a:spcBef>
+                <a:spcPts val="1000"/>
+              </a:spcBef>
+              <a:buClr>
+                <a:schemeClr val="bg1"/>
+              </a:buClr>
+              <a:buSzPct val="110000"/>
+              <a:buFontTx/>
+              <a:buBlip>
+                <a:blip r:embed="rId2">
+                  <a:extLst>
+                    <a:ext uri="{96DAC541-7B7A-43D3-8B79-37D633B846F1}">
+                      <asvg:svgBlip xmlns:asvg="http://schemas.microsoft.com/office/drawing/2016/SVG/main" r:embed="rId3"/>
+                    </a:ext>
+                  </a:extLst>
+                </a:blip>
+              </a:buBlip>
+              <a:defRPr sz="1200" kern="1200">
+                <a:solidFill>
+                  <a:schemeClr val="tx1"/>
+                </a:solidFill>
+                <a:latin typeface="+mn-lt"/>
+                <a:ea typeface="+mn-ea"/>
+                <a:cs typeface="+mn-cs"/>
+              </a:defRPr>
+            </a:lvl4pPr>
+            <a:lvl5pPr marL="1555750" indent="-285750" algn="l" defTabSz="914400" rtl="0" eaLnBrk="1" latinLnBrk="0" hangingPunct="1">
+              <a:lnSpc>
+                <a:spcPct val="100000"/>
+              </a:lnSpc>
+              <a:spcBef>
+                <a:spcPts val="1000"/>
+              </a:spcBef>
+              <a:buClr>
+                <a:schemeClr val="bg1"/>
+              </a:buClr>
+              <a:buSzPct val="110000"/>
+              <a:buFontTx/>
+              <a:buBlip>
+                <a:blip r:embed="rId2">
+                  <a:extLst>
+                    <a:ext uri="{96DAC541-7B7A-43D3-8B79-37D633B846F1}">
+                      <asvg:svgBlip xmlns:asvg="http://schemas.microsoft.com/office/drawing/2016/SVG/main" r:embed="rId3"/>
+                    </a:ext>
+                  </a:extLst>
+                </a:blip>
+              </a:buBlip>
+              <a:defRPr sz="1000" kern="1200">
+                <a:solidFill>
+                  <a:schemeClr val="tx1"/>
+                </a:solidFill>
+                <a:latin typeface="+mn-lt"/>
+                <a:ea typeface="+mn-ea"/>
+                <a:cs typeface="+mn-cs"/>
+              </a:defRPr>
+            </a:lvl5pPr>
+            <a:lvl6pPr marL="2514600" indent="-228600" algn="l" defTabSz="914400" rtl="0" eaLnBrk="1" latinLnBrk="0" hangingPunct="1">
+              <a:lnSpc>
+                <a:spcPct val="90000"/>
+              </a:lnSpc>
+              <a:spcBef>
+                <a:spcPts val="500"/>
+              </a:spcBef>
+              <a:buFont typeface="Arial" panose="020B0604020202020204" pitchFamily="34" charset="0"/>
+              <a:buChar char="•"/>
+              <a:defRPr sz="1800" kern="1200">
+                <a:solidFill>
+                  <a:schemeClr val="tx1"/>
+                </a:solidFill>
+                <a:latin typeface="+mn-lt"/>
+                <a:ea typeface="+mn-ea"/>
+                <a:cs typeface="+mn-cs"/>
+              </a:defRPr>
+            </a:lvl6pPr>
+            <a:lvl7pPr marL="2971800" indent="-228600" algn="l" defTabSz="914400" rtl="0" eaLnBrk="1" latinLnBrk="0" hangingPunct="1">
+              <a:lnSpc>
+                <a:spcPct val="90000"/>
+              </a:lnSpc>
+              <a:spcBef>
+                <a:spcPts val="500"/>
+              </a:spcBef>
+              <a:buFont typeface="Arial" panose="020B0604020202020204" pitchFamily="34" charset="0"/>
+              <a:buChar char="•"/>
+              <a:defRPr sz="1800" kern="1200">
+                <a:solidFill>
+                  <a:schemeClr val="tx1"/>
+                </a:solidFill>
+                <a:latin typeface="+mn-lt"/>
+                <a:ea typeface="+mn-ea"/>
+                <a:cs typeface="+mn-cs"/>
+              </a:defRPr>
+            </a:lvl7pPr>
+            <a:lvl8pPr marL="3429000" indent="-228600" algn="l" defTabSz="914400" rtl="0" eaLnBrk="1" latinLnBrk="0" hangingPunct="1">
+              <a:lnSpc>
+                <a:spcPct val="90000"/>
+              </a:lnSpc>
+              <a:spcBef>
+                <a:spcPts val="500"/>
+              </a:spcBef>
+              <a:buFont typeface="Arial" panose="020B0604020202020204" pitchFamily="34" charset="0"/>
+              <a:buChar char="•"/>
+              <a:defRPr sz="1800" kern="1200">
+                <a:solidFill>
+                  <a:schemeClr val="tx1"/>
+                </a:solidFill>
+                <a:latin typeface="+mn-lt"/>
+                <a:ea typeface="+mn-ea"/>
+                <a:cs typeface="+mn-cs"/>
+              </a:defRPr>
+            </a:lvl8pPr>
+            <a:lvl9pPr marL="3886200" indent="-228600" algn="l" defTabSz="914400" rtl="0" eaLnBrk="1" latinLnBrk="0" hangingPunct="1">
+              <a:lnSpc>
+                <a:spcPct val="90000"/>
+              </a:lnSpc>
+              <a:spcBef>
+                <a:spcPts val="500"/>
+              </a:spcBef>
+              <a:buFont typeface="Arial" panose="020B0604020202020204" pitchFamily="34" charset="0"/>
+              <a:buChar char="•"/>
+              <a:defRPr sz="1800" kern="1200">
+                <a:solidFill>
+                  <a:schemeClr val="tx1"/>
+                </a:solidFill>
+                <a:latin typeface="+mn-lt"/>
+                <a:ea typeface="+mn-ea"/>
+                <a:cs typeface="+mn-cs"/>
+              </a:defRPr>
+            </a:lvl9pPr>
+          </a:lstStyle>
+          <a:p>
+            <a:pPr marL="0" indent="0">
+              <a:buNone/>
+            </a:pPr>
+            <a:r>
+              <a:rPr lang="en-US" sz="2400" b="1" dirty="0"/>
+              <a:t>Advantages</a:t>
+            </a:r>
+          </a:p>
+          <a:p>
+            <a:pPr>
+              <a:spcAft>
+                <a:spcPts val="800"/>
+              </a:spcAft>
+            </a:pPr>
+            <a:r>
+              <a:rPr lang="en-US" dirty="0"/>
+              <a:t>Equal treatment of all titles and abstracts</a:t>
+            </a:r>
+          </a:p>
+          <a:p>
+            <a:pPr>
+              <a:spcAft>
+                <a:spcPts val="800"/>
+              </a:spcAft>
+            </a:pPr>
+            <a:r>
+              <a:rPr lang="en-US" dirty="0"/>
+              <a:t>It is most often accurate</a:t>
+            </a:r>
+          </a:p>
+          <a:p>
+            <a:pPr>
+              <a:spcAft>
+                <a:spcPts val="800"/>
+              </a:spcAft>
+            </a:pPr>
+            <a:r>
+              <a:rPr lang="en-US" dirty="0"/>
+              <a:t>It is fast</a:t>
+            </a:r>
+          </a:p>
+          <a:p>
+            <a:pPr>
+              <a:spcAft>
+                <a:spcPts val="800"/>
+              </a:spcAft>
+            </a:pPr>
+            <a:r>
+              <a:rPr lang="en-US" dirty="0"/>
+              <a:t>It is cheap </a:t>
+            </a:r>
+          </a:p>
+          <a:p>
+            <a:pPr>
+              <a:spcAft>
+                <a:spcPts val="800"/>
+              </a:spcAft>
+            </a:pPr>
+            <a:r>
+              <a:rPr lang="en-US" dirty="0"/>
+              <a:t>Can guard against human drifting. </a:t>
+            </a:r>
+          </a:p>
+          <a:p>
+            <a:pPr>
+              <a:spcAft>
+                <a:spcPts val="800"/>
+              </a:spcAft>
+            </a:pPr>
+            <a:r>
+              <a:rPr lang="en-US" dirty="0"/>
+              <a:t>Extra insurance that you have found all relevant records. It can also be used as a third screener.</a:t>
+            </a:r>
+          </a:p>
+          <a:p>
+            <a:pPr>
+              <a:spcAft>
+                <a:spcPts val="800"/>
+              </a:spcAft>
+            </a:pPr>
+            <a:r>
+              <a:rPr lang="en-US" dirty="0"/>
+              <a:t>Agnostic to data imbalance</a:t>
+            </a:r>
+          </a:p>
+          <a:p>
+            <a:pPr>
+              <a:spcAft>
+                <a:spcPts val="800"/>
+              </a:spcAft>
+            </a:pPr>
+            <a:r>
+              <a:rPr lang="da-DK" dirty="0"/>
+              <a:t>I</a:t>
+            </a:r>
+            <a:r>
+              <a:rPr lang="en-US" dirty="0"/>
+              <a:t>t’s flexible. That is, it can rapidly be fitted to many different situations. </a:t>
             </a:r>
           </a:p>
         </p:txBody>
@@ -49642,6 +49653,20 @@
             </a:pPr>
             <a:r>
               <a:rPr lang="en-US" dirty="0"/>
+              <a:t>Might not be agnostic to data imbalance.</a:t>
+            </a:r>
+          </a:p>
+          <a:p>
+            <a:pPr>
+              <a:spcBef>
+                <a:spcPts val="1200"/>
+              </a:spcBef>
+              <a:spcAft>
+                <a:spcPts val="1200"/>
+              </a:spcAft>
+            </a:pPr>
+            <a:r>
+              <a:rPr lang="en-US" dirty="0"/>
               <a:t>You can screen an incredibly large number of references in a very short time – in theory, 30.000 records per minute. </a:t>
             </a:r>
           </a:p>
@@ -49791,7 +49816,7 @@
           <a:p>
             <a:r>
               <a:rPr lang="en-US" dirty="0"/>
-              <a:t>Precondition for assessing AI screening</a:t>
+              <a:t>Quality assessing AI screening</a:t>
             </a:r>
           </a:p>
         </p:txBody>
@@ -49815,7 +49840,7 @@
         <p:spPr>
           <a:xfrm>
             <a:off x="1013519" y="1306326"/>
-            <a:ext cx="10612423" cy="997511"/>
+            <a:ext cx="10592881" cy="997511"/>
           </a:xfrm>
         </p:spPr>
         <p:txBody>
@@ -49824,11 +49849,11 @@
           <a:p>
             <a:r>
               <a:rPr lang="en-US" dirty="0"/>
-              <a:t>To know common human screening behavior</a:t>
+              <a:t>A precondition for quality assessing AI screening is to know common human screening behavior</a:t>
             </a:r>
             <a:r>
               <a:rPr lang="da-DK" dirty="0"/>
-              <a:t> </a:t>
+              <a:t>/performance</a:t>
             </a:r>
           </a:p>
           <a:p>
@@ -49884,8 +49909,8 @@
         </p:blipFill>
         <p:spPr>
           <a:xfrm>
-            <a:off x="1977656" y="2303837"/>
-            <a:ext cx="7740513" cy="4515300"/>
+            <a:off x="1977657" y="2504369"/>
+            <a:ext cx="7396744" cy="4314768"/>
           </a:xfrm>
           <a:prstGeom prst="rect">
             <a:avLst/>
@@ -49949,28 +49974,20 @@
           <a:lstStyle/>
           <a:p>
             <a:r>
+              <a:rPr lang="en-US" dirty="0"/>
+              <a:t>Quality assessing AI screening </a:t>
+            </a:r>
+            <a:r>
+              <a:rPr lang="da-DK" dirty="0"/>
+              <a:t>(</a:t>
+            </a:r>
+            <a:r>
               <a:rPr lang="da-DK" dirty="0" err="1"/>
-              <a:t>Precondition</a:t>
+              <a:t>continued</a:t>
             </a:r>
             <a:r>
               <a:rPr lang="da-DK" dirty="0"/>
-              <a:t> for </a:t>
-            </a:r>
-            <a:r>
-              <a:rPr lang="da-DK" dirty="0" err="1"/>
-              <a:t>assessing</a:t>
-            </a:r>
-            <a:r>
-              <a:rPr lang="da-DK" dirty="0"/>
-              <a:t> AI screening </a:t>
-            </a:r>
-            <a:r>
-              <a:rPr lang="da-DK" dirty="0" err="1"/>
-              <a:t>cont</a:t>
-            </a:r>
-            <a:r>
-              <a:rPr lang="da-DK" dirty="0"/>
-              <a:t>.</a:t>
+              <a:t>)</a:t>
             </a:r>
             <a:endParaRPr lang="en-US" dirty="0"/>
           </a:p>

</xml_diff>

<commit_message>
Fix benchmark framework link and update binary files
</commit_message>
<xml_diff>
--- a/screen-with-gpt-models.pptx
+++ b/screen-with-gpt-models.pptx
@@ -46374,10 +46374,10 @@
       </p:sp>
       <p:pic>
         <p:nvPicPr>
-          <p:cNvPr id="5" name="Picture 4">
+          <p:cNvPr id="6" name="Picture 5" descr="A robot touching a finger&#10;&#10;AI-generated content may be incorrect.">
             <a:extLst>
               <a:ext uri="{FF2B5EF4-FFF2-40B4-BE49-F238E27FC236}">
-                <a16:creationId xmlns:a16="http://schemas.microsoft.com/office/drawing/2014/main" id="{AB44329E-E87C-407A-AE52-8679855D09F7}"/>
+                <a16:creationId xmlns:a16="http://schemas.microsoft.com/office/drawing/2014/main" id="{65376440-27A5-0805-8CDA-9BBA38F5E911}"/>
               </a:ext>
             </a:extLst>
           </p:cNvPr>
@@ -46400,8 +46400,8 @@
         </p:blipFill>
         <p:spPr>
           <a:xfrm>
-            <a:off x="8575920" y="694541"/>
-            <a:ext cx="2090877" cy="2419530"/>
+            <a:off x="7579044" y="363738"/>
+            <a:ext cx="2739000" cy="2739000"/>
           </a:xfrm>
           <a:prstGeom prst="rect">
             <a:avLst/>
@@ -49497,11 +49497,11 @@
       </p:sp>
       <p:pic>
         <p:nvPicPr>
-          <p:cNvPr id="5" name="Picture 4">
+          <p:cNvPr id="6" name="Picture 5">
             <a:hlinkClick r:id="rId7"/>
             <a:extLst>
               <a:ext uri="{FF2B5EF4-FFF2-40B4-BE49-F238E27FC236}">
-                <a16:creationId xmlns:a16="http://schemas.microsoft.com/office/drawing/2014/main" id="{81ADB48C-5D14-F15A-668D-59C166D432D0}"/>
+                <a16:creationId xmlns:a16="http://schemas.microsoft.com/office/drawing/2014/main" id="{40D9B2F4-F21C-3C69-C0AF-55F3551DF31D}"/>
               </a:ext>
             </a:extLst>
           </p:cNvPr>
@@ -49518,8 +49518,8 @@
         </p:blipFill>
         <p:spPr>
           <a:xfrm>
-            <a:off x="7083950" y="4114078"/>
-            <a:ext cx="4889696" cy="1980216"/>
+            <a:off x="7083950" y="4378160"/>
+            <a:ext cx="4798510" cy="1716134"/>
           </a:xfrm>
           <a:prstGeom prst="rect">
             <a:avLst/>

</xml_diff>

<commit_message>
Last hand on the presentation and code
</commit_message>
<xml_diff>
--- a/screen-with-gpt-models.pptx
+++ b/screen-with-gpt-models.pptx
@@ -44891,7 +44891,7 @@
             </a:pPr>
             <a:r>
               <a:rPr lang="en-US" dirty="0"/>
-              <a:t>We have conducted three large-scale classification experiments with different levels of complexity in terms of the number of inclusion criteria. Herein we found that: </a:t>
+              <a:t>We have conducted three large-scale classification experiments with different levels of complexity in terms of the number of inclusion criteria. Here we found that: </a:t>
             </a:r>
             <a:br>
               <a:rPr lang="en-US" dirty="0"/>
@@ -44906,7 +44906,18 @@
             </a:pPr>
             <a:r>
               <a:rPr lang="en-US" dirty="0"/>
-              <a:t>GPT API models can perform on par with or in some cases even better typical human second screeners in high-quality systematic reviews (Vembye et al., 2025). All models yield recalls above 80% in all of our experiments while showing high exclusion rate as well. </a:t>
+              <a:t>GPT API models can perform on par with or in some cases even better than typical human second screeners in high-quality systematic reviews (Vembye et al., 2025). </a:t>
+            </a:r>
+          </a:p>
+          <a:p>
+            <a:pPr>
+              <a:spcAft>
+                <a:spcPts val="800"/>
+              </a:spcAft>
+            </a:pPr>
+            <a:r>
+              <a:rPr lang="en-US" dirty="0"/>
+              <a:t>All models yield recalls above 80% in all of our experiments while showing a high exclusion rate as well. </a:t>
             </a:r>
           </a:p>
           <a:p>
@@ -44928,11 +44939,11 @@
             </a:pPr>
             <a:r>
               <a:rPr lang="en-US" dirty="0"/>
-              <a:t>The GPT-4 and GPT-5 models outperform, </a:t>
+              <a:t>The GPT-4 and GPT-5 models outperform </a:t>
             </a:r>
             <a:r>
               <a:rPr lang="da-DK" dirty="0"/>
-              <a:t>the GPT-3.5-turbo model. </a:t>
+              <a:t>the GPT-3.5 models. </a:t>
             </a:r>
             <a:r>
               <a:rPr lang="en-US" dirty="0"/>
@@ -44951,15 +44962,7 @@
             </a:pPr>
             <a:r>
               <a:rPr lang="en-US" dirty="0"/>
-              <a:t>Moreover, our newest results suggest that GPT-4o-mini, which is 200 times cheaper than GPT-4, can perform on par the GPT-4, when using 10 screenings</a:t>
-            </a:r>
-            <a:r>
-              <a:rPr lang="da-DK" dirty="0"/>
-              <a:t>. </a:t>
-            </a:r>
-            <a:r>
-              <a:rPr lang="en-US" dirty="0"/>
-              <a:t>This is a game-changer in order to reduce the cost of this screening approach. </a:t>
+              <a:t>Moreover, we find that smaller models such as GPT-4o-mini and GPT-5-mini can be used for conducting reliable screenings. This has been a game-changer in order to reduce the cost of this screening approach. </a:t>
             </a:r>
           </a:p>
           <a:p>
@@ -45360,7 +45363,7 @@
             </a:pPr>
             <a:r>
               <a:rPr lang="en-US" dirty="0"/>
-              <a:t>Supporting American and Chinese big tech companies. </a:t>
+              <a:t>Supporting American and Chinese Big Tech companies. </a:t>
             </a:r>
           </a:p>
         </p:txBody>
@@ -46030,8 +46033,15 @@
             </a:pPr>
             <a:r>
               <a:rPr lang="en-US" dirty="0"/>
-              <a:t>THE FUTURE IS AI! I project that screening, as we know it today, will be largely be eradicated within the next 10 years. </a:t>
-            </a:r>
+              <a:t>THE FUTURE IS AI! I project that screening, as we know it today, will be largely eradicated within the next 10 years </a:t>
+            </a:r>
+            <a:r>
+              <a:rPr lang="en-US" dirty="0">
+                <a:sym typeface="Wingdings" panose="05000000000000000000" pitchFamily="2" charset="2"/>
+              </a:rPr>
+              <a:t> I believe that the relevancy of AIscreenR will be short-lived.</a:t>
+            </a:r>
+            <a:endParaRPr lang="en-US" dirty="0"/>
           </a:p>
           <a:p>
             <a:pPr marL="317500" lvl="1" indent="0">

</xml_diff>